<commit_message>
Frame the dissertation as three papers with venue targets
</commit_message>
<xml_diff>
--- a/slides/data-aware-scheduling.pptx
+++ b/slides/data-aware-scheduling.pptx
@@ -3557,7 +3557,7 @@
           <a:lstStyle/>
           <a:p>
             <a:r>
-              <a:t>The completed work establishes the platform; the proposal builds on it. Paper 1: model and four schedulers. Paper 2: data-aware, bounded, stress-tested. Proposal: repair the smallest affected part when a whole resource fails.</a:t>
+              <a:t>The whole PhD is three papers on one arc. Paper 1 — published at Cloud Summit 2025 — built the model and four schedulers. Paper 2 — the current submission — hardened it: data-aware, bounded, stress-tested. Paper 3 — this proposal — repairs the smallest affected region when a whole resource fails. Each paper answers the question the previous one left open.</a:t>
             </a:r>
           </a:p>
         </p:txBody>
@@ -26712,6 +26712,33 @@
               <a:t>Expected outcome:  faster recovery with less disturbance than full repartition, at near-reference quality</a:t>
             </a:r>
           </a:p>
+          <a:p>
+            <a:pPr>
+              <a:spcAft>
+                <a:spcPts val="700"/>
+              </a:spcAft>
+              <a:defRPr sz="1700">
+                <a:solidFill>
+                  <a:srgbClr val="232B33"/>
+                </a:solidFill>
+              </a:defRPr>
+            </a:pPr>
+          </a:p>
+          <a:p>
+            <a:pPr>
+              <a:spcAft>
+                <a:spcPts val="700"/>
+              </a:spcAft>
+              <a:defRPr sz="1700">
+                <a:solidFill>
+                  <a:srgbClr val="232B33"/>
+                </a:solidFill>
+              </a:defRPr>
+            </a:pPr>
+            <a:r>
+              <a:t>Paper 1 placed the workflow; Paper 2 priced its data and approximation; Paper 3 keeps it alive when the infrastructure fails.</a:t>
+            </a:r>
+          </a:p>
         </p:txBody>
       </p:sp>
     </p:spTree>
@@ -27730,7 +27757,7 @@
               </a:defRPr>
             </a:pPr>
             <a:r>
-              <a:t>One research arc, three stages</a:t>
+              <a:t>The dissertation as three papers</a:t>
             </a:r>
           </a:p>
         </p:txBody>
@@ -27879,7 +27906,7 @@
               </a:defRPr>
             </a:pPr>
             <a:r>
-              <a:t>DONE</a:t>
+              <a:t>PAPER 1</a:t>
             </a:r>
           </a:p>
         </p:txBody>
@@ -27914,7 +27941,7 @@
               </a:defRPr>
             </a:pPr>
             <a:r>
-              <a:t>Paper 1 — DAG task allocation across federated fog; model + 4 schedulers  (IEEE Cloud Summit 2025)</a:t>
+              <a:t>Efficient DAG task allocation across federated fog — the model + 4 schedulers.  Published: IEEE Cloud Summit 2025</a:t>
             </a:r>
           </a:p>
         </p:txBody>
@@ -27993,7 +28020,7 @@
               </a:defRPr>
             </a:pPr>
             <a:r>
-              <a:t>DONE</a:t>
+              <a:t>PAPER 2</a:t>
             </a:r>
           </a:p>
         </p:txBody>
@@ -28028,7 +28055,7 @@
               </a:defRPr>
             </a:pPr>
             <a:r>
-              <a:t>Paper 2 — data-aware approximate scheduling: bound, retry semantics, bandwidth degradation, scale limits</a:t>
+              <a:t>Data-aware scheduling of approximate DAG workflows — bound, retry semantics, bandwidth degradation, scale limits.  Submitted: CCGrid 2027</a:t>
             </a:r>
           </a:p>
         </p:txBody>
@@ -28107,7 +28134,7 @@
               </a:defRPr>
             </a:pPr>
             <a:r>
-              <a:t>PROPOSED</a:t>
+              <a:t>PAPER 3</a:t>
             </a:r>
           </a:p>
         </p:txBody>
@@ -28142,7 +28169,7 @@
               </a:defRPr>
             </a:pPr>
             <a:r>
-              <a:t>Dynamic partial repartitioning after a resource fails mid-workflow — repair only what broke</a:t>
+              <a:t>Dynamic partial repartitioning after resource failure — minimal-region repair, incremental paths.  This proposal — target: IPDPS / CCGrid 2028</a:t>
             </a:r>
           </a:p>
         </p:txBody>

</xml_diff>

<commit_message>
Replace math notation with plain words on intro slides
</commit_message>
<xml_diff>
--- a/slides/data-aware-scheduling.pptx
+++ b/slides/data-aware-scheduling.pptx
@@ -9265,7 +9265,7 @@
               </a:defRPr>
             </a:pPr>
             <a:r>
-              <a:t>Task graph G_T = (T, E): each task has an execution time, a full-run accuracy, and a set of nodes it is allowed to run on</a:t>
+              <a:t>The task graph has the work: each task has an execution time, a full-run accuracy, and a set of nodes it is allowed to run on</a:t>
             </a:r>
           </a:p>
           <a:p>
@@ -9280,7 +9280,7 @@
               </a:defRPr>
             </a:pPr>
             <a:r>
-              <a:t>  every edge carries D_ji bytes of dependency data</a:t>
+              <a:t>  every edge carries a chunk of dependency data</a:t>
             </a:r>
           </a:p>
           <a:p>
@@ -9295,7 +9295,7 @@
               </a:defRPr>
             </a:pPr>
             <a:r>
-              <a:t>Infrastructure graph G_R = (R, L): each node has capacity, memory and availability; each link has bandwidth and delay</a:t>
+              <a:t>The infrastructure graph has the machines: each node has capacity, memory and availability; each link has a bandwidth and a delay</a:t>
             </a:r>
           </a:p>
           <a:p>
@@ -9310,7 +9310,7 @@
               </a:defRPr>
             </a:pPr>
             <a:r>
-              <a:t>A partition pi maps tasks onto nodes, one eligible node per task</a:t>
+              <a:t>A placement maps tasks onto nodes, one eligible node per task</a:t>
             </a:r>
           </a:p>
           <a:p>
@@ -9325,7 +9325,7 @@
               </a:defRPr>
             </a:pPr>
             <a:r>
-              <a:t>A failure deletes a node from G_R and strands work in G_T</a:t>
+              <a:t>A failure deletes a node from one graph and strands work in the other</a:t>
             </a:r>
           </a:p>
         </p:txBody>
@@ -9380,7 +9380,7 @@
               </a:defRPr>
             </a:pPr>
             <a:r>
-              <a:t>Task DAG  G_T</a:t>
+              <a:t>Task DAG</a:t>
             </a:r>
           </a:p>
         </p:txBody>
@@ -9435,7 +9435,7 @@
               </a:defRPr>
             </a:pPr>
             <a:r>
-              <a:t>Infra  G_R</a:t>
+              <a:t>Infrastructure</a:t>
             </a:r>
           </a:p>
         </p:txBody>
@@ -27481,7 +27481,7 @@
               </a:defRPr>
             </a:pPr>
             <a:r>
-              <a:t>  every edge carries D_ji across a link of bandwidth B, so a transfer takes D_ji / B, often as long as the task itself</a:t>
+              <a:t>  every edge carries data that has to cross a link, and the transfer can take as long as the task itself</a:t>
             </a:r>
           </a:p>
           <a:p>
@@ -27511,7 +27511,7 @@
               </a:defRPr>
             </a:pPr>
             <a:r>
-              <a:t>  running a fraction l of a task costs l of the time and returns l of the accuracy; a flood model at 80% fidelity still warns in time</a:t>
+              <a:t>  running half of a task costs half the time and returns half the accuracy; a flood model at 80% fidelity still warns in time</a:t>
             </a:r>
           </a:p>
           <a:p>

</xml_diff>

<commit_message>
Replace paper folder with evaluated conference version
</commit_message>
<xml_diff>
--- a/slides/data-aware-scheduling.pptx
+++ b/slides/data-aware-scheduling.pptx
@@ -10985,40 +10985,16 @@
           </a:p>
         </p:txBody>
       </p:sp>
-      <p:pic>
-        <p:nvPicPr>
-          <p:cNvPr id="5" name="Picture 4" descr="scheduling-pipeline.png"/>
-          <p:cNvPicPr>
-            <a:picLocks noChangeAspect="1"/>
-          </p:cNvPicPr>
-          <p:nvPr/>
-        </p:nvPicPr>
-        <p:blipFill>
-          <a:blip r:embed="rId3"/>
-          <a:stretch>
-            <a:fillRect/>
-          </a:stretch>
-        </p:blipFill>
-        <p:spPr>
-          <a:xfrm>
-            <a:off x="640080" y="1188720"/>
-            <a:ext cx="6035040" cy="3688080"/>
-          </a:xfrm>
-          <a:prstGeom prst="rect">
-            <a:avLst/>
-          </a:prstGeom>
-        </p:spPr>
-      </p:pic>
-      <p:sp>
-        <p:nvSpPr>
-          <p:cNvPr id="6" name="TextBox 5"/>
+      <p:sp>
+        <p:nvSpPr>
+          <p:cNvPr id="5" name="TextBox 4"/>
           <p:cNvSpPr txBox="1"/>
           <p:nvPr/>
         </p:nvSpPr>
         <p:spPr>
           <a:xfrm>
-            <a:off x="7040880" y="1371600"/>
-            <a:ext cx="4754880" cy="5029200"/>
+            <a:off x="640080" y="1371600"/>
+            <a:ext cx="10972800" cy="5029200"/>
           </a:xfrm>
           <a:prstGeom prst="rect">
             <a:avLst/>
@@ -11035,14 +11011,14 @@
               <a:spcAft>
                 <a:spcPts val="1000"/>
               </a:spcAft>
-              <a:defRPr sz="1700">
+              <a:defRPr sz="2000">
                 <a:solidFill>
                   <a:srgbClr val="1A1A1A"/>
                 </a:solidFill>
               </a:defRPr>
             </a:pPr>
             <a:r>
-              <a:t>•  The exact solver is the benchmark</a:t>
+              <a:t>•  Every method prices transfers the same way, so the differences are algorithmic, not accounting</a:t>
             </a:r>
           </a:p>
           <a:p>
@@ -11050,14 +11026,14 @@
               <a:spcAft>
                 <a:spcPts val="1000"/>
               </a:spcAft>
-              <a:defRPr sz="1700">
+              <a:defRPr sz="2000">
                 <a:solidFill>
                   <a:srgbClr val="1A1A1A"/>
                 </a:solidFill>
               </a:defRPr>
             </a:pPr>
             <a:r>
-              <a:t>•  LP rounding relaxes, samples a machine per task, re-solves the fractions</a:t>
+              <a:t>•  The exact solver is the benchmark</a:t>
             </a:r>
           </a:p>
           <a:p>
@@ -11065,14 +11041,14 @@
               <a:spcAft>
                 <a:spcPts val="1000"/>
               </a:spcAft>
-              <a:defRPr sz="1700">
+              <a:defRPr sz="2000">
                 <a:solidFill>
                   <a:srgbClr val="1A1A1A"/>
                 </a:solidFill>
               </a:defRPr>
             </a:pPr>
             <a:r>
-              <a:t>•  The greedy places ready tasks by earliest finish; on a deadline miss it lowers the fraction and retries</a:t>
+              <a:t>•  LP rounding relaxes the integer choices, samples a machine per task, and re-solves the fractions</a:t>
             </a:r>
           </a:p>
           <a:p>
@@ -11080,7 +11056,22 @@
               <a:spcAft>
                 <a:spcPts val="1000"/>
               </a:spcAft>
-              <a:defRPr sz="1700">
+              <a:defRPr sz="2000">
+                <a:solidFill>
+                  <a:srgbClr val="1A1A1A"/>
+                </a:solidFill>
+              </a:defRPr>
+            </a:pPr>
+            <a:r>
+              <a:t>•  The greedy places ready tasks by earliest finish; on a deadline miss it lowers the fraction and retries</a:t>
+            </a:r>
+          </a:p>
+          <a:p>
+            <a:pPr>
+              <a:spcAft>
+                <a:spcPts val="1000"/>
+              </a:spcAft>
+              <a:defRPr sz="2000">
                 <a:solidFill>
                   <a:srgbClr val="1A1A1A"/>
                 </a:solidFill>

</xml_diff>

<commit_message>
Rebuild Figure 2 as a concrete wildfire-response example
Per advisor feedback: circular task nodes for the workflow DAG,
rectangular nodes for the fog resource network, realistic data
sizes (150-800 MB) and link rates (10-90 MB/s), and a named
pipeline (ingest, env prep, smoke detect, spread predict, fire
map, damage assess). The highlighted transfer - smoke-detection
frames crossing the slow f1-f3 link - works a 40 s example.
Figure is now generated by make_figures.py so it is reproducible.
</commit_message>
<xml_diff>
--- a/slides/data-aware-scheduling.pptx
+++ b/slides/data-aware-scheduling.pptx
@@ -9247,7 +9247,7 @@
         <p:spPr>
           <a:xfrm>
             <a:off x="6675120" y="1280160"/>
-            <a:ext cx="5120640" cy="3833707"/>
+            <a:ext cx="5120640" cy="2456902"/>
           </a:xfrm>
           <a:prstGeom prst="rect">
             <a:avLst/>
@@ -9284,7 +9284,7 @@
               </a:defRPr>
             </a:pPr>
             <a:r>
-              <a:t>A task graph (left) mapped onto the machine graph (right)</a:t>
+              <a:t>A wildfire workflow mapped onto the fog resource network</a:t>
             </a:r>
           </a:p>
         </p:txBody>

</xml_diff>

<commit_message>
Rebuild Figure 1 as the wildfire high-level design
Figure 1 is now the system story of the paper in one view: wildfire
monitoring inputs feed the federated fog network, the data-aware
scheduler places the six Fig. 2 tasks on the four fog nodes (f1
Gateway: T1-T3, f2 Shelter: T5, f3 Hospital: T4, f4 Mobile: T6),
inter-node links carry the same Mbp/s rates as Fig. 2b with the
80 Mbp/s bottleneck highlighted, and results flow to the emergency
operations centre. Editable .drawio source added; caption updated.
</commit_message>
<xml_diff>
--- a/slides/data-aware-scheduling.pptx
+++ b/slides/data-aware-scheduling.pptx
@@ -9247,7 +9247,7 @@
         <p:spPr>
           <a:xfrm>
             <a:off x="6675120" y="1280160"/>
-            <a:ext cx="5120640" cy="2535385"/>
+            <a:ext cx="5120640" cy="2546296"/>
           </a:xfrm>
           <a:prstGeom prst="rect">
             <a:avLst/>
@@ -22731,7 +22731,7 @@
         <p:spPr>
           <a:xfrm>
             <a:off x="6858000" y="1188720"/>
-            <a:ext cx="4937760" cy="3396343"/>
+            <a:ext cx="4937760" cy="6263640"/>
           </a:xfrm>
           <a:prstGeom prst="rect">
             <a:avLst/>

</xml_diff>

<commit_message>
Rebuild Figure 1 as orthogonal high-level design; unify figure style
Figure 1 is now the full system story: wildfire inputs feed the
federated fog network, the scheduler places Fig. 2's tasks on the
nodes (icons distinguish gateway/shelter/hospital/mobile), link
labels use Mbp/s with task data in MB, and results reach the EOC.
Rendered as a two-column figure* with orthogonal arrows.

Both figures now share the same plain font (no mathtext mixing),
transparent background, and GB-scale data sizes: the bottleneck
example is 1800 MB = 14400 Mb / 80 Mbp/s = 180 s.
</commit_message>
<xml_diff>
--- a/slides/data-aware-scheduling.pptx
+++ b/slides/data-aware-scheduling.pptx
@@ -9247,7 +9247,7 @@
         <p:spPr>
           <a:xfrm>
             <a:off x="6675120" y="1280160"/>
-            <a:ext cx="5120640" cy="2546296"/>
+            <a:ext cx="5120640" cy="2540333"/>
           </a:xfrm>
           <a:prstGeom prst="rect">
             <a:avLst/>
@@ -22731,7 +22731,7 @@
         <p:spPr>
           <a:xfrm>
             <a:off x="6858000" y="1188720"/>
-            <a:ext cx="4937760" cy="6263640"/>
+            <a:ext cx="4937760" cy="5845052"/>
           </a:xfrm>
           <a:prstGeom prst="rect">
             <a:avLst/>

</xml_diff>